<commit_message>
Update requirements and presentation
</commit_message>
<xml_diff>
--- a/DMS_Functions_in_ML_Group9.pptx
+++ b/DMS_Functions_in_ML_Group9.pptx
@@ -11399,7 +11399,7 @@
         </p:nvSpPr>
         <p:spPr>
           <a:xfrm>
-            <a:off x="457200" y="186863"/>
+            <a:off x="457200" y="223242"/>
             <a:ext cx="11247120" cy="553998"/>
           </a:xfrm>
           <a:prstGeom prst="rect">
@@ -11413,7 +11413,6 @@
           </a:bodyPr>
           <a:lstStyle/>
           <a:p>
-            <a:pPr algn="l"/>
             <a:r>
               <a:rPr lang="en-US" sz="3000" b="1" i="0" dirty="0">
                 <a:solidFill>
@@ -11421,7 +11420,25 @@
                 </a:solidFill>
                 <a:latin typeface="Cambria"/>
               </a:rPr>
-              <a:t>ML Model Code</a:t>
+              <a:t>ML Model Code    </a:t>
+            </a:r>
+            <a:r>
+              <a:rPr lang="en-US" sz="1600" b="1" dirty="0">
+                <a:solidFill>
+                  <a:srgbClr val="FFFFFF"/>
+                </a:solidFill>
+                <a:latin typeface="Cambria"/>
+              </a:rPr>
+              <a:t>(https://github.com/vigneshbs33/fml-dms)</a:t>
+            </a:r>
+            <a:r>
+              <a:rPr lang="en-US" sz="3000" b="1" i="0" dirty="0">
+                <a:solidFill>
+                  <a:srgbClr val="FFFFFF"/>
+                </a:solidFill>
+                <a:latin typeface="Cambria"/>
+              </a:rPr>
+              <a:t>  </a:t>
             </a:r>
             <a:endParaRPr sz="3000" b="1" i="0" dirty="0">
               <a:solidFill>
@@ -13673,7 +13690,6 @@
           </a:bodyPr>
           <a:lstStyle/>
           <a:p>
-            <a:pPr algn="l"/>
             <a:r>
               <a:rPr lang="en-US" sz="3000" b="1" i="0" dirty="0">
                 <a:solidFill>
@@ -13683,7 +13699,25 @@
               </a:rPr>
               <a:t>Live ML Demo</a:t>
             </a:r>
-            <a:endParaRPr sz="3000" b="1" i="0" dirty="0">
+            <a:r>
+              <a:rPr lang="en-US" sz="3000" b="1" dirty="0">
+                <a:solidFill>
+                  <a:srgbClr val="FFFFFF"/>
+                </a:solidFill>
+                <a:latin typeface="Cambria"/>
+              </a:rPr>
+              <a:t>   </a:t>
+            </a:r>
+            <a:r>
+              <a:rPr lang="en-US" sz="1600" b="1" dirty="0">
+                <a:solidFill>
+                  <a:srgbClr val="FFFFFF"/>
+                </a:solidFill>
+                <a:latin typeface="Cambria"/>
+              </a:rPr>
+              <a:t>(https://function-in-ml.streamlit.app)</a:t>
+            </a:r>
+            <a:endParaRPr sz="1600" b="1" i="0" dirty="0">
               <a:solidFill>
                 <a:srgbClr val="FFFFFF"/>
               </a:solidFill>

</xml_diff>